<commit_message>
Mets à jour les documents du mémoire
</commit_message>
<xml_diff>
--- a/MEMOIRE/Presentation_EduTrack_soutenance2.pptx
+++ b/MEMOIRE/Presentation_EduTrack_soutenance2.pptx
@@ -3073,14 +3073,14 @@
               <a:buNone/>
             </a:pPr>
             <a:r>
-              <a:rPr lang="en-US" sz="950" dirty="0">
+              <a:rPr lang="en-US" sz="1600" dirty="0">
                 <a:solidFill>
                   <a:srgbClr val="94A3B8"/>
                 </a:solidFill>
               </a:rPr>
               <a:t>EduTrack — Projet de Licence 3</a:t>
             </a:r>
-            <a:endParaRPr lang="en-US" sz="950" dirty="0"/>
+            <a:endParaRPr lang="en-US" sz="1600" dirty="0"/>
           </a:p>
         </p:txBody>
       </p:sp>
@@ -3109,14 +3109,14 @@
               <a:buNone/>
             </a:pPr>
             <a:r>
-              <a:rPr lang="en-US" sz="950" b="1" dirty="0">
+              <a:rPr lang="en-US" sz="1600" b="1" dirty="0">
                 <a:solidFill>
                   <a:srgbClr val="06B6D4"/>
                 </a:solidFill>
               </a:rPr>
               <a:t>10 / 10</a:t>
             </a:r>
-            <a:endParaRPr lang="en-US" sz="950" dirty="0"/>
+            <a:endParaRPr lang="en-US" sz="1600" dirty="0"/>
           </a:p>
         </p:txBody>
       </p:sp>
@@ -3219,7 +3219,7 @@
         </p:nvSpPr>
         <p:spPr>
           <a:xfrm>
-            <a:off x="0" y="0"/>
+            <a:off x="0" y="9832"/>
             <a:ext cx="12191695" cy="6858000"/>
           </a:xfrm>
           <a:prstGeom prst="rect">
@@ -3405,14 +3405,14 @@
               <a:buNone/>
             </a:pPr>
             <a:r>
-              <a:rPr lang="en-US" sz="950" dirty="0">
+              <a:rPr lang="en-US" sz="1600" dirty="0">
                 <a:solidFill>
                   <a:srgbClr val="94A3B8"/>
                 </a:solidFill>
               </a:rPr>
               <a:t>EduTrack — Projet de Licence 3</a:t>
             </a:r>
-            <a:endParaRPr lang="en-US" sz="950" dirty="0"/>
+            <a:endParaRPr lang="en-US" sz="1600" dirty="0"/>
           </a:p>
         </p:txBody>
       </p:sp>
@@ -3441,14 +3441,14 @@
               <a:buNone/>
             </a:pPr>
             <a:r>
-              <a:rPr lang="en-US" sz="950" b="1" dirty="0">
+              <a:rPr lang="en-US" sz="1600" b="1" dirty="0">
                 <a:solidFill>
                   <a:srgbClr val="06B6D4"/>
                 </a:solidFill>
               </a:rPr>
               <a:t>2 / 10</a:t>
             </a:r>
-            <a:endParaRPr lang="en-US" sz="950" dirty="0"/>
+            <a:endParaRPr lang="en-US" sz="1600" dirty="0"/>
           </a:p>
         </p:txBody>
       </p:sp>
@@ -4559,7 +4559,7 @@
         </p:nvSpPr>
         <p:spPr>
           <a:xfrm>
-            <a:off x="8778240" y="4013528"/>
+            <a:off x="8778240" y="4033192"/>
             <a:ext cx="5303520" cy="5303520"/>
           </a:xfrm>
           <a:prstGeom prst="ellipse">
@@ -4774,14 +4774,14 @@
               <a:buNone/>
             </a:pPr>
             <a:r>
-              <a:rPr lang="en-US" sz="950" dirty="0">
+              <a:rPr lang="en-US" sz="1600" dirty="0">
                 <a:solidFill>
                   <a:srgbClr val="94A3B8"/>
                 </a:solidFill>
               </a:rPr>
               <a:t>EduTrack — Projet de Licence 3</a:t>
             </a:r>
-            <a:endParaRPr lang="en-US" sz="950" dirty="0"/>
+            <a:endParaRPr lang="en-US" sz="1600" dirty="0"/>
           </a:p>
         </p:txBody>
       </p:sp>
@@ -4810,14 +4810,14 @@
               <a:buNone/>
             </a:pPr>
             <a:r>
-              <a:rPr lang="en-US" sz="950" b="1" dirty="0">
+              <a:rPr lang="en-US" sz="1600" b="1" dirty="0">
                 <a:solidFill>
                   <a:srgbClr val="06B6D4"/>
                 </a:solidFill>
               </a:rPr>
               <a:t>3 / 10</a:t>
             </a:r>
-            <a:endParaRPr lang="en-US" sz="950" dirty="0"/>
+            <a:endParaRPr lang="en-US" sz="1600" dirty="0"/>
           </a:p>
         </p:txBody>
       </p:sp>
@@ -5571,7 +5571,7 @@
         </p:nvSpPr>
         <p:spPr>
           <a:xfrm>
-            <a:off x="8778240" y="4023360"/>
+            <a:off x="8778240" y="4043024"/>
             <a:ext cx="5303520" cy="5303520"/>
           </a:xfrm>
           <a:prstGeom prst="ellipse">
@@ -5786,14 +5786,14 @@
               <a:buNone/>
             </a:pPr>
             <a:r>
-              <a:rPr lang="en-US" sz="950" dirty="0">
+              <a:rPr lang="en-US" sz="1600" dirty="0">
                 <a:solidFill>
                   <a:srgbClr val="94A3B8"/>
                 </a:solidFill>
               </a:rPr>
               <a:t>EduTrack — Projet de Licence 3</a:t>
             </a:r>
-            <a:endParaRPr lang="en-US" sz="950" dirty="0"/>
+            <a:endParaRPr lang="en-US" sz="1600" dirty="0"/>
           </a:p>
         </p:txBody>
       </p:sp>
@@ -5822,14 +5822,14 @@
               <a:buNone/>
             </a:pPr>
             <a:r>
-              <a:rPr lang="en-US" sz="950" b="1" dirty="0">
+              <a:rPr lang="en-US" sz="1600" b="1" dirty="0">
                 <a:solidFill>
                   <a:srgbClr val="06B6D4"/>
                 </a:solidFill>
               </a:rPr>
               <a:t>4 / 10</a:t>
             </a:r>
-            <a:endParaRPr lang="en-US" sz="950" dirty="0"/>
+            <a:endParaRPr lang="en-US" sz="1600" dirty="0"/>
           </a:p>
         </p:txBody>
       </p:sp>
@@ -7052,7 +7052,7 @@
         </p:nvSpPr>
         <p:spPr>
           <a:xfrm>
-            <a:off x="8778240" y="4023360"/>
+            <a:off x="8778240" y="4033192"/>
             <a:ext cx="5303520" cy="5303520"/>
           </a:xfrm>
           <a:prstGeom prst="ellipse">
@@ -7081,7 +7081,7 @@
         </p:nvSpPr>
         <p:spPr>
           <a:xfrm>
-            <a:off x="0" y="0"/>
+            <a:off x="0" y="9832"/>
             <a:ext cx="12191695" cy="6858000"/>
           </a:xfrm>
           <a:prstGeom prst="rect">
@@ -7267,14 +7267,14 @@
               <a:buNone/>
             </a:pPr>
             <a:r>
-              <a:rPr lang="en-US" sz="950" dirty="0">
+              <a:rPr lang="en-US" sz="1600" dirty="0">
                 <a:solidFill>
                   <a:srgbClr val="94A3B8"/>
                 </a:solidFill>
               </a:rPr>
               <a:t>EduTrack — Projet de Licence 3</a:t>
             </a:r>
-            <a:endParaRPr lang="en-US" sz="950" dirty="0"/>
+            <a:endParaRPr lang="en-US" sz="1600" dirty="0"/>
           </a:p>
         </p:txBody>
       </p:sp>
@@ -7303,14 +7303,14 @@
               <a:buNone/>
             </a:pPr>
             <a:r>
-              <a:rPr lang="en-US" sz="950" b="1" dirty="0">
+              <a:rPr lang="en-US" sz="1600" b="1" dirty="0">
                 <a:solidFill>
                   <a:srgbClr val="06B6D4"/>
                 </a:solidFill>
               </a:rPr>
               <a:t>5 / 10</a:t>
             </a:r>
-            <a:endParaRPr lang="en-US" sz="950" dirty="0"/>
+            <a:endParaRPr lang="en-US" sz="1600" dirty="0"/>
           </a:p>
         </p:txBody>
       </p:sp>
@@ -7516,7 +7516,31 @@
                   <a:srgbClr val="FFFFFF"/>
                 </a:solidFill>
               </a:rPr>
-              <a:t>Technologies &amp; frameworks</a:t>
+              <a:t>Technologies &amp; </a:t>
+            </a:r>
+            <a:r>
+              <a:rPr lang="en-US" sz="2900" b="1" dirty="0" err="1">
+                <a:solidFill>
+                  <a:srgbClr val="FFFFFF"/>
+                </a:solidFill>
+              </a:rPr>
+              <a:t>Outils</a:t>
+            </a:r>
+            <a:r>
+              <a:rPr lang="en-US" sz="2900" b="1" dirty="0">
+                <a:solidFill>
+                  <a:srgbClr val="FFFFFF"/>
+                </a:solidFill>
+              </a:rPr>
+              <a:t> </a:t>
+            </a:r>
+            <a:r>
+              <a:rPr lang="en-US" sz="2900" b="1" dirty="0" err="1">
+                <a:solidFill>
+                  <a:srgbClr val="FFFFFF"/>
+                </a:solidFill>
+              </a:rPr>
+              <a:t>utilisée</a:t>
             </a:r>
             <a:endParaRPr lang="en-US" sz="2900" dirty="0"/>
           </a:p>
@@ -7649,14 +7673,14 @@
               <a:buNone/>
             </a:pPr>
             <a:r>
-              <a:rPr lang="en-US" sz="950" dirty="0">
+              <a:rPr lang="en-US" sz="1600" dirty="0">
                 <a:solidFill>
                   <a:srgbClr val="94A3B8"/>
                 </a:solidFill>
               </a:rPr>
               <a:t>EduTrack — Projet de Licence 3</a:t>
             </a:r>
-            <a:endParaRPr lang="en-US" sz="950" dirty="0"/>
+            <a:endParaRPr lang="en-US" sz="1600" dirty="0"/>
           </a:p>
         </p:txBody>
       </p:sp>
@@ -7685,14 +7709,14 @@
               <a:buNone/>
             </a:pPr>
             <a:r>
-              <a:rPr lang="en-US" sz="950" b="1" dirty="0">
+              <a:rPr lang="en-US" sz="1600" b="1" dirty="0">
                 <a:solidFill>
                   <a:srgbClr val="06B6D4"/>
                 </a:solidFill>
               </a:rPr>
               <a:t>6 / 10</a:t>
             </a:r>
-            <a:endParaRPr lang="en-US" sz="950" dirty="0"/>
+            <a:endParaRPr lang="en-US" sz="1600" dirty="0"/>
           </a:p>
         </p:txBody>
       </p:sp>
@@ -8860,7 +8884,7 @@
         </p:nvSpPr>
         <p:spPr>
           <a:xfrm>
-            <a:off x="0" y="0"/>
+            <a:off x="0" y="19664"/>
             <a:ext cx="12191695" cy="6858000"/>
           </a:xfrm>
           <a:prstGeom prst="rect">
@@ -9046,14 +9070,14 @@
               <a:buNone/>
             </a:pPr>
             <a:r>
-              <a:rPr lang="en-US" sz="950" dirty="0">
+              <a:rPr lang="en-US" sz="1600" dirty="0">
                 <a:solidFill>
                   <a:srgbClr val="94A3B8"/>
                 </a:solidFill>
               </a:rPr>
               <a:t>EduTrack — Projet de Licence 3</a:t>
             </a:r>
-            <a:endParaRPr lang="en-US" sz="950" dirty="0"/>
+            <a:endParaRPr lang="en-US" sz="1600" dirty="0"/>
           </a:p>
         </p:txBody>
       </p:sp>
@@ -9082,14 +9106,14 @@
               <a:buNone/>
             </a:pPr>
             <a:r>
-              <a:rPr lang="en-US" sz="950" b="1" dirty="0">
+              <a:rPr lang="en-US" sz="1600" b="1" dirty="0">
                 <a:solidFill>
                   <a:srgbClr val="06B6D4"/>
                 </a:solidFill>
               </a:rPr>
               <a:t>7 / 10</a:t>
             </a:r>
-            <a:endParaRPr lang="en-US" sz="950" dirty="0"/>
+            <a:endParaRPr lang="en-US" sz="1600" dirty="0"/>
           </a:p>
         </p:txBody>
       </p:sp>
@@ -9122,7 +9146,7 @@
       </p:sp>
       <p:pic>
         <p:nvPicPr>
-          <p:cNvPr id="13" name="Image 1" descr="MEMOIRE/Capture d'ecran application web et mobile/page_accueil_mobile.jpg"/>
+          <p:cNvPr id="13" name="Image 1"/>
           <p:cNvPicPr>
             <a:picLocks noChangeAspect="1"/>
           </p:cNvPicPr>
@@ -9854,14 +9878,14 @@
               <a:buNone/>
             </a:pPr>
             <a:r>
-              <a:rPr lang="en-US" sz="950" dirty="0">
+              <a:rPr lang="en-US" sz="1600" dirty="0">
                 <a:solidFill>
                   <a:srgbClr val="94A3B8"/>
                 </a:solidFill>
               </a:rPr>
               <a:t>EduTrack — Projet de Licence 3</a:t>
             </a:r>
-            <a:endParaRPr lang="en-US" sz="950" dirty="0"/>
+            <a:endParaRPr lang="en-US" sz="1600" dirty="0"/>
           </a:p>
         </p:txBody>
       </p:sp>
@@ -9890,14 +9914,14 @@
               <a:buNone/>
             </a:pPr>
             <a:r>
-              <a:rPr lang="en-US" sz="950" b="1" dirty="0">
+              <a:rPr lang="en-US" sz="1600" b="1" dirty="0">
                 <a:solidFill>
                   <a:srgbClr val="06B6D4"/>
                 </a:solidFill>
               </a:rPr>
               <a:t>8 / 10</a:t>
             </a:r>
-            <a:endParaRPr lang="en-US" sz="950" dirty="0"/>
+            <a:endParaRPr lang="en-US" sz="1600" dirty="0"/>
           </a:p>
         </p:txBody>
       </p:sp>
@@ -10186,14 +10210,14 @@
               <a:buNone/>
             </a:pPr>
             <a:r>
-              <a:rPr lang="en-US" sz="950" dirty="0">
+              <a:rPr lang="en-US" sz="1600" dirty="0">
                 <a:solidFill>
                   <a:srgbClr val="94A3B8"/>
                 </a:solidFill>
               </a:rPr>
               <a:t>EduTrack — Projet de Licence 3</a:t>
             </a:r>
-            <a:endParaRPr lang="en-US" sz="950" dirty="0"/>
+            <a:endParaRPr lang="en-US" sz="1600" dirty="0"/>
           </a:p>
         </p:txBody>
       </p:sp>
@@ -10222,14 +10246,14 @@
               <a:buNone/>
             </a:pPr>
             <a:r>
-              <a:rPr lang="en-US" sz="950" b="1" dirty="0">
+              <a:rPr lang="en-US" sz="1600" b="1" dirty="0">
                 <a:solidFill>
                   <a:srgbClr val="06B6D4"/>
                 </a:solidFill>
               </a:rPr>
               <a:t>9 / 10</a:t>
             </a:r>
-            <a:endParaRPr lang="en-US" sz="950" dirty="0"/>
+            <a:endParaRPr lang="en-US" sz="1600" dirty="0"/>
           </a:p>
         </p:txBody>
       </p:sp>

</xml_diff>